<commit_message>
Move agro-complex legend off the map so it cannot overlap
Co-Authored-By: Claude Sonnet 5.5 <noreply@anthropic.com>
Claude-Session: https://claude.ai/code/session_01PfagTkBBfn3ShTm5bX9M45
</commit_message>
<xml_diff>
--- a/slide_agrokompleks_klasterizatsiya.pptx
+++ b/slide_agrokompleks_klasterizatsiya.pptx
@@ -6302,8 +6302,8 @@
         </p:nvSpPr>
         <p:spPr>
           <a:xfrm>
-            <a:off x="4823242" y="2212847"/>
-            <a:ext cx="182880" cy="182880"/>
+            <a:off x="7680960" y="2340864"/>
+            <a:ext cx="201168" cy="201168"/>
           </a:xfrm>
           <a:prstGeom prst="diamond">
             <a:avLst/>
@@ -6331,8 +6331,8 @@
         </p:nvSpPr>
         <p:spPr>
           <a:xfrm>
-            <a:off x="5189002" y="2148839"/>
-            <a:ext cx="2192474" cy="310896"/>
+            <a:off x="8092440" y="2286000"/>
+            <a:ext cx="1965959" cy="384048"/>
           </a:xfrm>
           <a:prstGeom prst="rect">
             <a:avLst/>
@@ -6347,7 +6347,7 @@
           <a:p>
             <a:pPr algn="l"/>
             <a:r>
-              <a:rPr sz="1250" b="0">
+              <a:rPr sz="1300" b="0">
                 <a:solidFill>
                   <a:srgbClr val="062D3F"/>
                 </a:solidFill>
@@ -6366,8 +6366,8 @@
         </p:nvSpPr>
         <p:spPr>
           <a:xfrm>
-            <a:off x="4823242" y="2578607"/>
-            <a:ext cx="182880" cy="182880"/>
+            <a:off x="7680960" y="2816352"/>
+            <a:ext cx="201168" cy="201168"/>
           </a:xfrm>
           <a:prstGeom prst="diamond">
             <a:avLst/>
@@ -6395,8 +6395,8 @@
         </p:nvSpPr>
         <p:spPr>
           <a:xfrm>
-            <a:off x="5189002" y="2514599"/>
-            <a:ext cx="2192474" cy="310896"/>
+            <a:off x="8092440" y="2761488"/>
+            <a:ext cx="1965959" cy="384048"/>
           </a:xfrm>
           <a:prstGeom prst="rect">
             <a:avLst/>
@@ -6411,7 +6411,7 @@
           <a:p>
             <a:pPr algn="l"/>
             <a:r>
-              <a:rPr sz="1250" b="0">
+              <a:rPr sz="1300" b="0">
                 <a:solidFill>
                   <a:srgbClr val="062D3F"/>
                 </a:solidFill>
@@ -6430,8 +6430,8 @@
         </p:nvSpPr>
         <p:spPr>
           <a:xfrm>
-            <a:off x="4823242" y="2926079"/>
-            <a:ext cx="237744" cy="201168"/>
+            <a:off x="7680960" y="3282696"/>
+            <a:ext cx="256032" cy="219456"/>
           </a:xfrm>
           <a:prstGeom prst="rect">
             <a:avLst/>
@@ -6461,8 +6461,8 @@
         </p:nvSpPr>
         <p:spPr>
           <a:xfrm>
-            <a:off x="5189002" y="2880359"/>
-            <a:ext cx="2192474" cy="566928"/>
+            <a:off x="8092440" y="3236976"/>
+            <a:ext cx="1965959" cy="658368"/>
           </a:xfrm>
           <a:prstGeom prst="rect">
             <a:avLst/>
@@ -6477,7 +6477,7 @@
           <a:p>
             <a:pPr algn="l"/>
             <a:r>
-              <a:rPr sz="1250" b="0">
+              <a:rPr sz="1300" b="0">
                 <a:solidFill>
                   <a:srgbClr val="062D3F"/>
                 </a:solidFill>
@@ -6496,8 +6496,8 @@
         </p:nvSpPr>
         <p:spPr>
           <a:xfrm>
-            <a:off x="4823242" y="3547871"/>
-            <a:ext cx="237744" cy="201168"/>
+            <a:off x="7680960" y="4032504"/>
+            <a:ext cx="256032" cy="219456"/>
           </a:xfrm>
           <a:prstGeom prst="rect">
             <a:avLst/>
@@ -6527,8 +6527,8 @@
         </p:nvSpPr>
         <p:spPr>
           <a:xfrm>
-            <a:off x="5189002" y="3502151"/>
-            <a:ext cx="2192474" cy="566928"/>
+            <a:off x="8092440" y="3986784"/>
+            <a:ext cx="1965959" cy="658368"/>
           </a:xfrm>
           <a:prstGeom prst="rect">
             <a:avLst/>
@@ -6543,7 +6543,7 @@
           <a:p>
             <a:pPr algn="l"/>
             <a:r>
-              <a:rPr sz="1250" b="0">
+              <a:rPr sz="1300" b="0">
                 <a:solidFill>
                   <a:srgbClr val="062D3F"/>
                 </a:solidFill>
@@ -6562,8 +6562,8 @@
         </p:nvSpPr>
         <p:spPr>
           <a:xfrm>
-            <a:off x="4823242" y="4169663"/>
-            <a:ext cx="237744" cy="201168"/>
+            <a:off x="7680960" y="4782312"/>
+            <a:ext cx="256032" cy="219456"/>
           </a:xfrm>
           <a:prstGeom prst="rect">
             <a:avLst/>
@@ -6593,8 +6593,8 @@
         </p:nvSpPr>
         <p:spPr>
           <a:xfrm>
-            <a:off x="5189002" y="4123943"/>
-            <a:ext cx="2192474" cy="310896"/>
+            <a:off x="8092440" y="4736592"/>
+            <a:ext cx="1965959" cy="384048"/>
           </a:xfrm>
           <a:prstGeom prst="rect">
             <a:avLst/>
@@ -6609,7 +6609,7 @@
           <a:p>
             <a:pPr algn="l"/>
             <a:r>
-              <a:rPr sz="1250" b="0">
+              <a:rPr sz="1300" b="0">
                 <a:solidFill>
                   <a:srgbClr val="062D3F"/>
                 </a:solidFill>
@@ -6628,8 +6628,8 @@
         </p:nvSpPr>
         <p:spPr>
           <a:xfrm>
-            <a:off x="4823242" y="4535423"/>
-            <a:ext cx="237744" cy="201168"/>
+            <a:off x="7680960" y="5257800"/>
+            <a:ext cx="256032" cy="219456"/>
           </a:xfrm>
           <a:prstGeom prst="rect">
             <a:avLst/>
@@ -6659,8 +6659,8 @@
         </p:nvSpPr>
         <p:spPr>
           <a:xfrm>
-            <a:off x="5189002" y="4489703"/>
-            <a:ext cx="2192474" cy="310896"/>
+            <a:off x="8092440" y="5212080"/>
+            <a:ext cx="1965959" cy="384048"/>
           </a:xfrm>
           <a:prstGeom prst="rect">
             <a:avLst/>
@@ -6675,7 +6675,7 @@
           <a:p>
             <a:pPr algn="l"/>
             <a:r>
-              <a:rPr sz="1250" b="0">
+              <a:rPr sz="1300" b="0">
                 <a:solidFill>
                   <a:srgbClr val="062D3F"/>
                 </a:solidFill>

</xml_diff>

<commit_message>
Move agro-complex legend closer to the map
Co-Authored-By: Claude Sonnet 5.5 <noreply@anthropic.com>
Claude-Session: https://claude.ai/code/session_01PfagTkBBfn3ShTm5bX9M45
</commit_message>
<xml_diff>
--- a/slide_agrokompleks_klasterizatsiya.pptx
+++ b/slide_agrokompleks_klasterizatsiya.pptx
@@ -6302,7 +6302,7 @@
         </p:nvSpPr>
         <p:spPr>
           <a:xfrm>
-            <a:off x="7680960" y="2340864"/>
+            <a:off x="6035040" y="2340864"/>
             <a:ext cx="201168" cy="201168"/>
           </a:xfrm>
           <a:prstGeom prst="diamond">
@@ -6331,8 +6331,8 @@
         </p:nvSpPr>
         <p:spPr>
           <a:xfrm>
-            <a:off x="8092440" y="2286000"/>
-            <a:ext cx="1965959" cy="384048"/>
+            <a:off x="6446520" y="2286000"/>
+            <a:ext cx="2423159" cy="384048"/>
           </a:xfrm>
           <a:prstGeom prst="rect">
             <a:avLst/>
@@ -6366,7 +6366,7 @@
         </p:nvSpPr>
         <p:spPr>
           <a:xfrm>
-            <a:off x="7680960" y="2816352"/>
+            <a:off x="6035040" y="2816352"/>
             <a:ext cx="201168" cy="201168"/>
           </a:xfrm>
           <a:prstGeom prst="diamond">
@@ -6395,8 +6395,8 @@
         </p:nvSpPr>
         <p:spPr>
           <a:xfrm>
-            <a:off x="8092440" y="2761488"/>
-            <a:ext cx="1965959" cy="384048"/>
+            <a:off x="6446520" y="2761488"/>
+            <a:ext cx="2423159" cy="384048"/>
           </a:xfrm>
           <a:prstGeom prst="rect">
             <a:avLst/>
@@ -6430,7 +6430,7 @@
         </p:nvSpPr>
         <p:spPr>
           <a:xfrm>
-            <a:off x="7680960" y="3282696"/>
+            <a:off x="6035040" y="3282696"/>
             <a:ext cx="256032" cy="219456"/>
           </a:xfrm>
           <a:prstGeom prst="rect">
@@ -6461,8 +6461,8 @@
         </p:nvSpPr>
         <p:spPr>
           <a:xfrm>
-            <a:off x="8092440" y="3236976"/>
-            <a:ext cx="1965959" cy="658368"/>
+            <a:off x="6446520" y="3236976"/>
+            <a:ext cx="2423159" cy="658368"/>
           </a:xfrm>
           <a:prstGeom prst="rect">
             <a:avLst/>
@@ -6496,7 +6496,7 @@
         </p:nvSpPr>
         <p:spPr>
           <a:xfrm>
-            <a:off x="7680960" y="4032504"/>
+            <a:off x="6035040" y="4032504"/>
             <a:ext cx="256032" cy="219456"/>
           </a:xfrm>
           <a:prstGeom prst="rect">
@@ -6527,8 +6527,8 @@
         </p:nvSpPr>
         <p:spPr>
           <a:xfrm>
-            <a:off x="8092440" y="3986784"/>
-            <a:ext cx="1965959" cy="658368"/>
+            <a:off x="6446520" y="3986784"/>
+            <a:ext cx="2423159" cy="658368"/>
           </a:xfrm>
           <a:prstGeom prst="rect">
             <a:avLst/>
@@ -6562,7 +6562,7 @@
         </p:nvSpPr>
         <p:spPr>
           <a:xfrm>
-            <a:off x="7680960" y="4782312"/>
+            <a:off x="6035040" y="4782312"/>
             <a:ext cx="256032" cy="219456"/>
           </a:xfrm>
           <a:prstGeom prst="rect">
@@ -6593,8 +6593,8 @@
         </p:nvSpPr>
         <p:spPr>
           <a:xfrm>
-            <a:off x="8092440" y="4736592"/>
-            <a:ext cx="1965959" cy="384048"/>
+            <a:off x="6446520" y="4736592"/>
+            <a:ext cx="2423159" cy="384048"/>
           </a:xfrm>
           <a:prstGeom prst="rect">
             <a:avLst/>
@@ -6628,7 +6628,7 @@
         </p:nvSpPr>
         <p:spPr>
           <a:xfrm>
-            <a:off x="7680960" y="5257800"/>
+            <a:off x="6035040" y="5257800"/>
             <a:ext cx="256032" cy="219456"/>
           </a:xfrm>
           <a:prstGeom prst="rect">
@@ -6659,8 +6659,8 @@
         </p:nvSpPr>
         <p:spPr>
           <a:xfrm>
-            <a:off x="8092440" y="5212080"/>
-            <a:ext cx="1965959" cy="384048"/>
+            <a:off x="6446520" y="5212080"/>
+            <a:ext cx="2423159" cy="384048"/>
           </a:xfrm>
           <a:prstGeom prst="rect">
             <a:avLst/>

</xml_diff>